<commit_message>
Preserve portable Delivery Lab source and actual release results
</commit_message>
<xml_diff>
--- a/public/pitch.pptx
+++ b/public/pitch.pptx
@@ -3088,7 +3088,7 @@
     <p:bg>
       <p:bgPr>
         <a:solidFill>
-          <a:srgbClr val="0B1118"/>
+          <a:srgbClr val="0B1017"/>
         </a:solidFill>
         <a:effectLst/>
       </p:bgPr>
@@ -3108,7 +3108,7 @@
         </p:nvSpPr>
         <p:spPr>
           <a:xfrm>
-            <a:off x="777240" y="685800"/>
+            <a:off x="777240" y="594360"/>
             <a:ext cx="10607040" cy="457200"/>
           </a:xfrm>
           <a:prstGeom prst="rect">
@@ -3123,15 +3123,15 @@
           <a:lstStyle/>
           <a:p>
             <a:pPr>
-              <a:defRPr sz="1400">
+              <a:defRPr sz="1300">
                 <a:solidFill>
-                  <a:srgbClr val="80E5C0"/>
+                  <a:srgbClr val="83E8CE"/>
                 </a:solidFill>
-                <a:latin typeface="Arial"/>
+                <a:latin typeface="Aptos"/>
               </a:defRPr>
             </a:pPr>
             <a:r>
-              <a:t>Forkline</a:t>
+              <a:t>FORKLINE / DELIVERY LAB</a:t>
             </a:r>
           </a:p>
         </p:txBody>
@@ -3144,7 +3144,7 @@
         </p:nvSpPr>
         <p:spPr>
           <a:xfrm>
-            <a:off x="777240" y="1463040"/>
+            <a:off x="777240" y="1325880"/>
             <a:ext cx="10607040" cy="1828800"/>
           </a:xfrm>
           <a:prstGeom prst="rect">
@@ -3161,26 +3161,26 @@
             <a:pPr>
               <a:defRPr sz="3600">
                 <a:solidFill>
-                  <a:srgbClr val="EAF4F5"/>
+                  <a:srgbClr val="EFF5F9"/>
                 </a:solidFill>
-                <a:latin typeface="Arial"/>
+                <a:latin typeface="Aptos"/>
               </a:defRPr>
             </a:pPr>
             <a:r>
-              <a:t>The transaction vanished.</a:t>
+              <a:t>The event vanished.</a:t>
             </a:r>
           </a:p>
           <a:p>
             <a:pPr>
               <a:defRPr sz="3600">
                 <a:solidFill>
-                  <a:srgbClr val="EAF4F5"/>
+                  <a:srgbClr val="EFF5F9"/>
                 </a:solidFill>
-                <a:latin typeface="Arial"/>
+                <a:latin typeface="Aptos"/>
               </a:defRPr>
             </a:pPr>
             <a:r>
-              <a:t>Your delivery did not.</a:t>
+              <a:t>The ticket did not.</a:t>
             </a:r>
           </a:p>
         </p:txBody>
@@ -3193,8 +3193,8 @@
         </p:nvSpPr>
         <p:spPr>
           <a:xfrm>
-            <a:off x="777240" y="3520440"/>
-            <a:ext cx="10607040" cy="1920240"/>
+            <a:off x="777240" y="3474720"/>
+            <a:ext cx="10607040" cy="2011680"/>
           </a:xfrm>
           <a:prstGeom prst="rect">
             <a:avLst/>
@@ -3208,15 +3208,15 @@
           <a:lstStyle/>
           <a:p>
             <a:pPr>
-              <a:defRPr sz="2000">
+              <a:defRPr sz="2200">
                 <a:solidFill>
-                  <a:srgbClr val="A0B3C1"/>
+                  <a:srgbClr val="A6B5C3"/>
                 </a:solidFill>
-                <a:latin typeface="Arial"/>
+                <a:latin typeface="Aptos"/>
               </a:defRPr>
             </a:pPr>
             <a:r>
-              <a:t>A reorg rehearsal workbench for Web3 fulfillment, membership and ticketing developers.</a:t>
+              <a:t>Test the gap between queue approval and outside work. A reproducible local integration for Web3 ticketing, membership and fulfillment developers.</a:t>
             </a:r>
           </a:p>
         </p:txBody>
@@ -3246,13 +3246,13 @@
             <a:pPr>
               <a:defRPr sz="1000">
                 <a:solidFill>
-                  <a:srgbClr val="A0B3C1"/>
+                  <a:srgbClr val="A6B5C3"/>
                 </a:solidFill>
-                <a:latin typeface="Arial"/>
+                <a:latin typeface="Aptos"/>
               </a:defRPr>
             </a:pPr>
             <a:r>
-              <a:t>FORKLINE    /    01    /    05    |    MIT    |    AI-assisted original project</a:t>
+              <a:t>FORKLINE  /  01 OF 05    ·    LOCAL TEST FIXTURES    ·    MIT    ·    AI-ASSISTED ORIGINAL WORK</a:t>
             </a:r>
           </a:p>
         </p:txBody>
@@ -3271,7 +3271,7 @@
     <p:bg>
       <p:bgPr>
         <a:solidFill>
-          <a:srgbClr val="0B1118"/>
+          <a:srgbClr val="0B1017"/>
         </a:solidFill>
         <a:effectLst/>
       </p:bgPr>
@@ -3291,7 +3291,7 @@
         </p:nvSpPr>
         <p:spPr>
           <a:xfrm>
-            <a:off x="777240" y="685800"/>
+            <a:off x="777240" y="594360"/>
             <a:ext cx="10607040" cy="457200"/>
           </a:xfrm>
           <a:prstGeom prst="rect">
@@ -3306,15 +3306,15 @@
           <a:lstStyle/>
           <a:p>
             <a:pPr>
-              <a:defRPr sz="1400">
+              <a:defRPr sz="1300">
                 <a:solidFill>
-                  <a:srgbClr val="80E5C0"/>
+                  <a:srgbClr val="83E8CE"/>
                 </a:solidFill>
-                <a:latin typeface="Arial"/>
+                <a:latin typeface="Aptos"/>
               </a:defRPr>
             </a:pPr>
             <a:r>
-              <a:t>PROBLEM</a:t>
+              <a:t>01 / THE FAILURE</a:t>
             </a:r>
           </a:p>
         </p:txBody>
@@ -3327,7 +3327,7 @@
         </p:nvSpPr>
         <p:spPr>
           <a:xfrm>
-            <a:off x="777240" y="1463040"/>
+            <a:off x="777240" y="1325880"/>
             <a:ext cx="10607040" cy="1828800"/>
           </a:xfrm>
           <a:prstGeom prst="rect">
@@ -3344,13 +3344,13 @@
             <a:pPr>
               <a:defRPr sz="3600">
                 <a:solidFill>
-                  <a:srgbClr val="EAF4F5"/>
+                  <a:srgbClr val="EFF5F9"/>
                 </a:solidFill>
-                <a:latin typeface="Arial"/>
+                <a:latin typeface="Aptos"/>
               </a:defRPr>
             </a:pPr>
             <a:r>
-              <a:t>One event. Two different commitments.</a:t>
+              <a:t>Approval is not a receipt.</a:t>
             </a:r>
           </a:p>
         </p:txBody>
@@ -3363,8 +3363,8 @@
         </p:nvSpPr>
         <p:spPr>
           <a:xfrm>
-            <a:off x="777240" y="3520440"/>
-            <a:ext cx="10607040" cy="1920240"/>
+            <a:off x="777240" y="3474720"/>
+            <a:ext cx="10607040" cy="2011680"/>
           </a:xfrm>
           <a:prstGeom prst="rect">
             <a:avLst/>
@@ -3378,15 +3378,15 @@
           <a:lstStyle/>
           <a:p>
             <a:pPr>
-              <a:defRPr sz="2000">
+              <a:defRPr sz="2200">
                 <a:solidFill>
-                  <a:srgbClr val="A0B3C1"/>
+                  <a:srgbClr val="A6B5C3"/>
                 </a:solidFill>
-                <a:latin typeface="Arial"/>
+                <a:latin typeface="Aptos"/>
               </a:defRPr>
             </a:pPr>
             <a:r>
-              <a:t>A node can report an event that is later orphaned. An external action can already be complete. Rolling back an index is not rolling back a delivery.</a:t>
+              <a:t>An event can be eligible at enqueue and orphaned at dispatch. A receiver can commit while its acknowledgement is lost. Neither rolling back an index nor blindly retrying resolves both cases.</a:t>
             </a:r>
           </a:p>
         </p:txBody>
@@ -3416,13 +3416,13 @@
             <a:pPr>
               <a:defRPr sz="1000">
                 <a:solidFill>
-                  <a:srgbClr val="A0B3C1"/>
+                  <a:srgbClr val="A6B5C3"/>
                 </a:solidFill>
-                <a:latin typeface="Arial"/>
+                <a:latin typeface="Aptos"/>
               </a:defRPr>
             </a:pPr>
             <a:r>
-              <a:t>FORKLINE    /    02    /    05    |    MIT    |    AI-assisted original project</a:t>
+              <a:t>FORKLINE  /  02 OF 05    ·    LOCAL TEST FIXTURES    ·    MIT    ·    AI-ASSISTED ORIGINAL WORK</a:t>
             </a:r>
           </a:p>
         </p:txBody>
@@ -3441,7 +3441,7 @@
     <p:bg>
       <p:bgPr>
         <a:solidFill>
-          <a:srgbClr val="0B1118"/>
+          <a:srgbClr val="0B1017"/>
         </a:solidFill>
         <a:effectLst/>
       </p:bgPr>
@@ -3461,7 +3461,7 @@
         </p:nvSpPr>
         <p:spPr>
           <a:xfrm>
-            <a:off x="777240" y="685800"/>
+            <a:off x="777240" y="594360"/>
             <a:ext cx="10607040" cy="457200"/>
           </a:xfrm>
           <a:prstGeom prst="rect">
@@ -3476,15 +3476,15 @@
           <a:lstStyle/>
           <a:p>
             <a:pPr>
-              <a:defRPr sz="1400">
+              <a:defRPr sz="1300">
                 <a:solidFill>
-                  <a:srgbClr val="80E5C0"/>
+                  <a:srgbClr val="83E8CE"/>
                 </a:solidFill>
-                <a:latin typeface="Arial"/>
+                <a:latin typeface="Aptos"/>
               </a:defRPr>
             </a:pPr>
             <a:r>
-              <a:t>SOLUTION</a:t>
+              <a:t>02 / THE BUILD</a:t>
             </a:r>
           </a:p>
         </p:txBody>
@@ -3497,7 +3497,7 @@
         </p:nvSpPr>
         <p:spPr>
           <a:xfrm>
-            <a:off x="777240" y="1463040"/>
+            <a:off x="777240" y="1325880"/>
             <a:ext cx="10607040" cy="1828800"/>
           </a:xfrm>
           <a:prstGeom prst="rect">
@@ -3514,13 +3514,13 @@
             <a:pPr>
               <a:defRPr sz="3600">
                 <a:solidFill>
-                  <a:srgbClr val="EAF4F5"/>
+                  <a:srgbClr val="EFF5F9"/>
                 </a:solidFill>
-                <a:latin typeface="Arial"/>
+                <a:latin typeface="Aptos"/>
               </a:defRPr>
             </a:pPr>
             <a:r>
-              <a:t>Execute a fork. Rehearse your response.</a:t>
+              <a:t>A real worker. A separate receiver.</a:t>
             </a:r>
           </a:p>
         </p:txBody>
@@ -3533,8 +3533,8 @@
         </p:nvSpPr>
         <p:spPr>
           <a:xfrm>
-            <a:off x="777240" y="3520440"/>
-            <a:ext cx="10607040" cy="1920240"/>
+            <a:off x="777240" y="3474720"/>
+            <a:ext cx="10607040" cy="2011680"/>
           </a:xfrm>
           <a:prstGeom prst="rect">
             <a:avLst/>
@@ -3548,15 +3548,15 @@
           <a:lstStyle/>
           <a:p>
             <a:pPr>
-              <a:defRPr sz="2000">
+              <a:defRPr sz="2200">
                 <a:solidFill>
-                  <a:srgbClr val="A0B3C1"/>
+                  <a:srgbClr val="A6B5C3"/>
                 </a:solidFill>
-                <a:latin typeface="Arial"/>
+                <a:latin typeface="Aptos"/>
               </a:defRPr>
             </a:pPr>
             <a:r>
-              <a:t>Compile and deploy a Solidity fixture on a local EVM. Mine competing histories. Replay node-reported heads, choose a confirmation policy and simulate delivery acknowledgments.</a:t>
+              <a:t>Compiled Solidity fixture and pinned EVM observations → shared eligibility engine → SQLite outbox → loopback HTTP receiver → separate ticket ledger. Restart the worker and reconcile its receipt.</a:t>
             </a:r>
           </a:p>
         </p:txBody>
@@ -3586,13 +3586,13 @@
             <a:pPr>
               <a:defRPr sz="1000">
                 <a:solidFill>
-                  <a:srgbClr val="A0B3C1"/>
+                  <a:srgbClr val="A6B5C3"/>
                 </a:solidFill>
-                <a:latin typeface="Arial"/>
+                <a:latin typeface="Aptos"/>
               </a:defRPr>
             </a:pPr>
             <a:r>
-              <a:t>FORKLINE    /    03    /    05    |    MIT    |    AI-assisted original project</a:t>
+              <a:t>FORKLINE  /  03 OF 05    ·    LOCAL TEST FIXTURES    ·    MIT    ·    AI-ASSISTED ORIGINAL WORK</a:t>
             </a:r>
           </a:p>
         </p:txBody>
@@ -3611,7 +3611,7 @@
     <p:bg>
       <p:bgPr>
         <a:solidFill>
-          <a:srgbClr val="0B1118"/>
+          <a:srgbClr val="0B1017"/>
         </a:solidFill>
         <a:effectLst/>
       </p:bgPr>
@@ -3631,7 +3631,7 @@
         </p:nvSpPr>
         <p:spPr>
           <a:xfrm>
-            <a:off x="777240" y="685800"/>
+            <a:off x="777240" y="594360"/>
             <a:ext cx="10607040" cy="457200"/>
           </a:xfrm>
           <a:prstGeom prst="rect">
@@ -3646,15 +3646,15 @@
           <a:lstStyle/>
           <a:p>
             <a:pPr>
-              <a:defRPr sz="1400">
+              <a:defRPr sz="1300">
                 <a:solidFill>
-                  <a:srgbClr val="80E5C0"/>
+                  <a:srgbClr val="83E8CE"/>
                 </a:solidFill>
-                <a:latin typeface="Arial"/>
+                <a:latin typeface="Aptos"/>
               </a:defRPr>
             </a:pPr>
             <a:r>
-              <a:t>CONTRIBUTION</a:t>
+              <a:t>03 / THE DIFFERENCE</a:t>
             </a:r>
           </a:p>
         </p:txBody>
@@ -3667,7 +3667,7 @@
         </p:nvSpPr>
         <p:spPr>
           <a:xfrm>
-            <a:off x="777240" y="1463040"/>
+            <a:off x="777240" y="1325880"/>
             <a:ext cx="10607040" cy="1828800"/>
           </a:xfrm>
           <a:prstGeom prst="rect">
@@ -3684,13 +3684,26 @@
             <a:pPr>
               <a:defRPr sz="3600">
                 <a:solidFill>
-                  <a:srgbClr val="EAF4F5"/>
+                  <a:srgbClr val="EFF5F9"/>
                 </a:solidFill>
-                <a:latin typeface="Arial"/>
+                <a:latin typeface="Aptos"/>
               </a:defRPr>
             </a:pPr>
             <a:r>
-              <a:t>Make the irreversible boundary visible.</a:t>
+              <a:t>Reproduce the failure.</a:t>
+            </a:r>
+          </a:p>
+          <a:p>
+            <a:pPr>
+              <a:defRPr sz="3600">
+                <a:solidFill>
+                  <a:srgbClr val="EFF5F9"/>
+                </a:solidFill>
+                <a:latin typeface="Aptos"/>
+              </a:defRPr>
+            </a:pPr>
+            <a:r>
+              <a:t>Keep the outside effect.</a:t>
             </a:r>
           </a:p>
         </p:txBody>
@@ -3703,8 +3716,8 @@
         </p:nvSpPr>
         <p:spPr>
           <a:xfrm>
-            <a:off x="777240" y="3520440"/>
-            <a:ext cx="10607040" cy="1920240"/>
+            <a:off x="777240" y="3474720"/>
+            <a:ext cx="10607040" cy="2011680"/>
           </a:xfrm>
           <a:prstGeom prst="rect">
             <a:avLst/>
@@ -3718,15 +3731,15 @@
           <a:lstStyle/>
           <a:p>
             <a:pPr>
-              <a:defRPr sz="2000">
+              <a:defRPr sz="2200">
                 <a:solidFill>
-                  <a:srgbClr val="A0B3C1"/>
+                  <a:srgbClr val="A6B5C3"/>
                 </a:solidFill>
-                <a:latin typeface="Arial"/>
+                <a:latin typeface="Aptos"/>
               </a:defRPr>
             </a:pPr>
             <a:r>
-              <a:t>Separate canonical observations from acknowledged work. Deduplicate repeated events. Latch an incident after evidence is lost. Save and replay the same decisions. This combines established techniques; it does not invent reorg handling.</a:t>
+              <a:t>Same waiting rule, same order: the enqueue-only consumer issues one orphaned fixture ticket; Forkline holds the command. If a ticket already exists, retain its receipt, latch the incident and stop further guarded delivery.</a:t>
             </a:r>
           </a:p>
         </p:txBody>
@@ -3756,13 +3769,13 @@
             <a:pPr>
               <a:defRPr sz="1000">
                 <a:solidFill>
-                  <a:srgbClr val="A0B3C1"/>
+                  <a:srgbClr val="A6B5C3"/>
                 </a:solidFill>
-                <a:latin typeface="Arial"/>
+                <a:latin typeface="Aptos"/>
               </a:defRPr>
             </a:pPr>
             <a:r>
-              <a:t>FORKLINE    /    04    /    05    |    MIT    |    AI-assisted original project</a:t>
+              <a:t>FORKLINE  /  04 OF 05    ·    LOCAL TEST FIXTURES    ·    MIT    ·    AI-ASSISTED ORIGINAL WORK</a:t>
             </a:r>
           </a:p>
         </p:txBody>
@@ -3781,7 +3794,7 @@
     <p:bg>
       <p:bgPr>
         <a:solidFill>
-          <a:srgbClr val="0B1118"/>
+          <a:srgbClr val="0B1017"/>
         </a:solidFill>
         <a:effectLst/>
       </p:bgPr>
@@ -3801,7 +3814,7 @@
         </p:nvSpPr>
         <p:spPr>
           <a:xfrm>
-            <a:off x="777240" y="685800"/>
+            <a:off x="777240" y="594360"/>
             <a:ext cx="10607040" cy="457200"/>
           </a:xfrm>
           <a:prstGeom prst="rect">
@@ -3816,15 +3829,15 @@
           <a:lstStyle/>
           <a:p>
             <a:pPr>
-              <a:defRPr sz="1400">
+              <a:defRPr sz="1300">
                 <a:solidFill>
-                  <a:srgbClr val="80E5C0"/>
+                  <a:srgbClr val="83E8CE"/>
                 </a:solidFill>
-                <a:latin typeface="Arial"/>
+                <a:latin typeface="Aptos"/>
               </a:defRPr>
             </a:pPr>
             <a:r>
-              <a:t>VALIDATION / FUTURE</a:t>
+              <a:t>04 / EVIDENCE &amp; NEXT STEP</a:t>
             </a:r>
           </a:p>
         </p:txBody>
@@ -3837,7 +3850,7 @@
         </p:nvSpPr>
         <p:spPr>
           <a:xfrm>
-            <a:off x="777240" y="1463040"/>
+            <a:off x="777240" y="1325880"/>
             <a:ext cx="10607040" cy="1828800"/>
           </a:xfrm>
           <a:prstGeom prst="rect">
@@ -3854,13 +3867,13 @@
             <a:pPr>
               <a:defRPr sz="3600">
                 <a:solidFill>
-                  <a:srgbClr val="EAF4F5"/>
+                  <a:srgbClr val="EFF5F9"/>
                 </a:solidFill>
-                <a:latin typeface="Arial"/>
+                <a:latin typeface="Aptos"/>
               </a:defRPr>
             </a:pPr>
             <a:r>
-              <a:t>A tested rehearsal, not a payment gateway.</a:t>
+              <a:t>An integration test you can rerun.</a:t>
             </a:r>
           </a:p>
         </p:txBody>
@@ -3873,8 +3886,8 @@
         </p:nvSpPr>
         <p:spPr>
           <a:xfrm>
-            <a:off x="777240" y="3520440"/>
-            <a:ext cx="10607040" cy="1920240"/>
+            <a:off x="777240" y="3474720"/>
+            <a:ext cx="10607040" cy="2011680"/>
           </a:xfrm>
           <a:prstGeom prst="rect">
             <a:avLst/>
@@ -3888,15 +3901,15 @@
           <a:lstStyle/>
           <a:p>
             <a:pPr>
-              <a:defRPr sz="2000">
+              <a:defRPr sz="2200">
                 <a:solidFill>
-                  <a:srgbClr val="A0B3C1"/>
+                  <a:srgbClr val="A6B5C3"/>
                 </a:solidFill>
-                <a:latin typeface="Arial"/>
+                <a:latin typeface="Aptos"/>
               </a:defRPr>
             </a:pPr>
             <a:r>
-              <a:t>49 engine tests, 9 actual local-EVM checks and 18 browser workflows passed. No real assets or live consensus. Next: maintained-node adapters, production outbox integration and developer field testing. No revenue or financial benefit is claimed.</a:t>
+              <a:t>Executed database and HTTP checks include dropped acknowledgements, true child-process death, restart, receipt lookup and duplicate commands. No real assets or field savings. Next: maintained live-node adapter and an authorized developer pilot.</a:t>
             </a:r>
           </a:p>
         </p:txBody>
@@ -3926,13 +3939,13 @@
             <a:pPr>
               <a:defRPr sz="1000">
                 <a:solidFill>
-                  <a:srgbClr val="A0B3C1"/>
+                  <a:srgbClr val="A6B5C3"/>
                 </a:solidFill>
-                <a:latin typeface="Arial"/>
+                <a:latin typeface="Aptos"/>
               </a:defRPr>
             </a:pPr>
             <a:r>
-              <a:t>FORKLINE    /    05    /    05    |    MIT    |    AI-assisted original project</a:t>
+              <a:t>FORKLINE  /  05 OF 05    ·    LOCAL TEST FIXTURES    ·    MIT    ·    AI-ASSISTED ORIGINAL WORK</a:t>
             </a:r>
           </a:p>
         </p:txBody>

</xml_diff>